<commit_message>
feat: add lab slot 14
</commit_message>
<xml_diff>
--- a/slides/Chapter 04/4.2 Similarity Measures for Cluster Analysis.pptx
+++ b/slides/Chapter 04/4.2 Similarity Measures for Cluster Analysis.pptx
@@ -2865,8 +2865,8 @@
         </p:nvSpPr>
         <p:spPr>
           <a:xfrm>
-            <a:off x="429100" y="687314"/>
-            <a:ext cx="6001500" cy="3427500"/>
+            <a:off x="384175" y="687388"/>
+            <a:ext cx="6091238" cy="3427412"/>
           </a:xfrm>
           <a:custGeom>
             <a:avLst/>
@@ -31906,14 +31906,14 @@
               <a:buChar char="●"/>
             </a:pPr>
             <a:r>
-              <a:rPr lang="en-GB" sz="1800">
+              <a:rPr lang="en-GB" sz="1800" dirty="0">
                 <a:solidFill>
                   <a:srgbClr val="1F1F1F"/>
                 </a:solidFill>
               </a:rPr>
               <a:t>Correlation between two variables X1 and X2 is the standard covariance, obtained by normalizing the covariance with the standard deviation of each variable </a:t>
             </a:r>
-            <a:endParaRPr sz="1800">
+            <a:endParaRPr sz="1800" dirty="0">
               <a:solidFill>
                 <a:srgbClr val="1F1F1F"/>
               </a:solidFill>
@@ -31933,14 +31933,14 @@
               <a:buNone/>
             </a:pPr>
             <a:r>
-              <a:rPr lang="en-GB" sz="1800">
+              <a:rPr lang="en-GB" sz="1800" dirty="0">
                 <a:solidFill>
                   <a:srgbClr val="1F1F1F"/>
                 </a:solidFill>
               </a:rPr>
               <a:t> </a:t>
             </a:r>
-            <a:endParaRPr sz="1800">
+            <a:endParaRPr sz="1800" dirty="0">
               <a:solidFill>
                 <a:srgbClr val="1F1F1F"/>
               </a:solidFill>
@@ -31964,14 +31964,14 @@
               <a:buChar char="●"/>
             </a:pPr>
             <a:r>
-              <a:rPr lang="en-GB" sz="1800">
+              <a:rPr lang="en-GB" sz="1800" dirty="0">
                 <a:solidFill>
                   <a:srgbClr val="1F1F1F"/>
                 </a:solidFill>
               </a:rPr>
               <a:t>Sample correlation for two attributes X1 and X2: </a:t>
             </a:r>
-            <a:endParaRPr sz="1800">
+            <a:endParaRPr sz="1800" dirty="0">
               <a:solidFill>
                 <a:srgbClr val="1F1F1F"/>
               </a:solidFill>
@@ -31991,14 +31991,14 @@
               <a:buNone/>
             </a:pPr>
             <a:r>
-              <a:rPr lang="en-GB" sz="1800">
+              <a:rPr lang="en-GB" sz="1800" dirty="0">
                 <a:solidFill>
                   <a:srgbClr val="1F1F1F"/>
                 </a:solidFill>
               </a:rPr>
               <a:t>where n is the number of tuples, µ1 and µ2 are the respective means of X1 and X2 , σ1 and σ2 are the respective standard deviation of X1 and X2  </a:t>
             </a:r>
-            <a:endParaRPr sz="1800">
+            <a:endParaRPr sz="1800" dirty="0">
               <a:solidFill>
                 <a:srgbClr val="1F1F1F"/>
               </a:solidFill>
@@ -32022,14 +32022,14 @@
               <a:buChar char="●"/>
             </a:pPr>
             <a:r>
-              <a:rPr lang="en-GB" sz="1800">
+              <a:rPr lang="en-GB" sz="1800" dirty="0">
                 <a:solidFill>
                   <a:srgbClr val="1F1F1F"/>
                 </a:solidFill>
               </a:rPr>
               <a:t>If ρ12 &gt; 0: A and B are positively correlated (X1’s values increase as X2’s)  </a:t>
             </a:r>
-            <a:endParaRPr sz="1800">
+            <a:endParaRPr sz="1800" dirty="0">
               <a:solidFill>
                 <a:srgbClr val="1F1F1F"/>
               </a:solidFill>
@@ -32053,14 +32053,14 @@
               <a:buChar char="○"/>
             </a:pPr>
             <a:r>
-              <a:rPr lang="en-GB" sz="1800">
+              <a:rPr lang="en-GB" sz="1800" dirty="0">
                 <a:solidFill>
                   <a:srgbClr val="1F1F1F"/>
                 </a:solidFill>
               </a:rPr>
               <a:t>The higher, the stronger correlation  </a:t>
             </a:r>
-            <a:endParaRPr sz="1800">
+            <a:endParaRPr sz="1800" dirty="0">
               <a:solidFill>
                 <a:srgbClr val="1F1F1F"/>
               </a:solidFill>
@@ -32084,14 +32084,14 @@
               <a:buChar char="●"/>
             </a:pPr>
             <a:r>
-              <a:rPr lang="en-GB" sz="1800">
+              <a:rPr lang="en-GB" sz="1800" dirty="0">
                 <a:solidFill>
                   <a:srgbClr val="1F1F1F"/>
                 </a:solidFill>
               </a:rPr>
               <a:t>If ρ12 = 0: independent (under the same assumption as discussed in co-variance)  </a:t>
             </a:r>
-            <a:endParaRPr sz="1800">
+            <a:endParaRPr sz="1800" dirty="0">
               <a:solidFill>
                 <a:srgbClr val="1F1F1F"/>
               </a:solidFill>
@@ -32115,14 +32115,14 @@
               <a:buChar char="●"/>
             </a:pPr>
             <a:r>
-              <a:rPr lang="en-GB" sz="1800">
+              <a:rPr lang="en-GB" sz="1800" dirty="0">
                 <a:solidFill>
                   <a:srgbClr val="1F1F1F"/>
                 </a:solidFill>
               </a:rPr>
               <a:t>If ρ12 &lt; 0: negatively correlated</a:t>
             </a:r>
-            <a:endParaRPr sz="1800">
+            <a:endParaRPr sz="1800" dirty="0">
               <a:solidFill>
                 <a:srgbClr val="1F1F1F"/>
               </a:solidFill>
@@ -32292,7 +32292,7 @@
         </p:blipFill>
         <p:spPr>
           <a:xfrm>
-            <a:off x="3657600" y="2314575"/>
+            <a:off x="1555750" y="2553749"/>
             <a:ext cx="1828800" cy="514350"/>
           </a:xfrm>
           <a:prstGeom prst="rect">
@@ -32320,7 +32320,7 @@
         </p:blipFill>
         <p:spPr>
           <a:xfrm>
-            <a:off x="5888840" y="2314574"/>
+            <a:off x="5882490" y="2498724"/>
             <a:ext cx="3144310" cy="759875"/>
           </a:xfrm>
           <a:prstGeom prst="rect">

</xml_diff>